<commit_message>
Refine bird phylogeny figure to reference style
</commit_message>
<xml_diff>
--- a/tasks/bird_phylogeny_new_records_mctavish/figures/fig_s1_phylogeny_matching_diagnostics.pptx
+++ b/tasks/bird_phylogeny_new_records_mctavish/figures/fig_s1_phylogeny_matching_diagnostics.pptx
@@ -4796,7 +4796,7 @@
               <a:avLst/>
             </a:prstGeom>
             <a:solidFill>
-              <a:srgbClr val="EA8344">
+              <a:srgbClr val="19E51E">
                 <a:alpha val="100000"/>
               </a:srgbClr>
             </a:solidFill>
@@ -4831,7 +4831,7 @@
               <a:avLst/>
             </a:prstGeom>
             <a:solidFill>
-              <a:srgbClr val="DB8D00">
+              <a:srgbClr val="FFF000">
                 <a:alpha val="100000"/>
               </a:srgbClr>
             </a:solidFill>
@@ -4866,7 +4866,7 @@
               <a:avLst/>
             </a:prstGeom>
             <a:solidFill>
-              <a:srgbClr val="C99700">
+              <a:srgbClr val="00E8F2">
                 <a:alpha val="100000"/>
               </a:srgbClr>
             </a:solidFill>
@@ -4901,7 +4901,7 @@
               <a:avLst/>
             </a:prstGeom>
             <a:solidFill>
-              <a:srgbClr val="B2A000">
+              <a:srgbClr val="FF1A1A">
                 <a:alpha val="100000"/>
               </a:srgbClr>
             </a:solidFill>
@@ -4936,7 +4936,7 @@
               <a:avLst/>
             </a:prstGeom>
             <a:solidFill>
-              <a:srgbClr val="97A800">
+              <a:srgbClr val="FF8ED1">
                 <a:alpha val="100000"/>
               </a:srgbClr>
             </a:solidFill>
@@ -4971,7 +4971,7 @@
               <a:avLst/>
             </a:prstGeom>
             <a:solidFill>
-              <a:srgbClr val="73AF00">
+              <a:srgbClr val="13D7E0">
                 <a:alpha val="100000"/>
               </a:srgbClr>
             </a:solidFill>
@@ -5006,7 +5006,7 @@
               <a:avLst/>
             </a:prstGeom>
             <a:solidFill>
-              <a:srgbClr val="39B505">
+              <a:srgbClr val="FF8C25">
                 <a:alpha val="100000"/>
               </a:srgbClr>
             </a:solidFill>
@@ -5041,7 +5041,7 @@
               <a:avLst/>
             </a:prstGeom>
             <a:solidFill>
-              <a:srgbClr val="00BA51">
+              <a:srgbClr val="9CCAE1">
                 <a:alpha val="100000"/>
               </a:srgbClr>
             </a:solidFill>
@@ -5076,7 +5076,7 @@
               <a:avLst/>
             </a:prstGeom>
             <a:solidFill>
-              <a:srgbClr val="00BD78">
+              <a:srgbClr val="B2E84D">
                 <a:alpha val="100000"/>
               </a:srgbClr>
             </a:solidFill>
@@ -5111,7 +5111,7 @@
               <a:avLst/>
             </a:prstGeom>
             <a:solidFill>
-              <a:srgbClr val="00BF99">
+              <a:srgbClr val="FFBF52">
                 <a:alpha val="100000"/>
               </a:srgbClr>
             </a:solidFill>
@@ -5146,7 +5146,7 @@
               <a:avLst/>
             </a:prstGeom>
             <a:solidFill>
-              <a:srgbClr val="00BFB5">
+              <a:srgbClr val="39D6D0">
                 <a:alpha val="100000"/>
               </a:srgbClr>
             </a:solidFill>
@@ -5181,7 +5181,7 @@
               <a:avLst/>
             </a:prstGeom>
             <a:solidFill>
-              <a:srgbClr val="00BCCF">
+              <a:srgbClr val="8E6AE8">
                 <a:alpha val="100000"/>
               </a:srgbClr>
             </a:solidFill>
@@ -5216,7 +5216,7 @@
               <a:avLst/>
             </a:prstGeom>
             <a:solidFill>
-              <a:srgbClr val="00B6E4">
+              <a:srgbClr val="7CC7F2">
                 <a:alpha val="100000"/>
               </a:srgbClr>
             </a:solidFill>
@@ -5251,7 +5251,7 @@
               <a:avLst/>
             </a:prstGeom>
             <a:solidFill>
-              <a:srgbClr val="00ADF5">
+              <a:srgbClr val="A8D8F8">
                 <a:alpha val="100000"/>
               </a:srgbClr>
             </a:solidFill>
@@ -5286,7 +5286,7 @@
               <a:avLst/>
             </a:prstGeom>
             <a:solidFill>
-              <a:srgbClr val="48A1FF">
+              <a:srgbClr val="71BFFF">
                 <a:alpha val="100000"/>
               </a:srgbClr>
             </a:solidFill>
@@ -5321,7 +5321,7 @@
               <a:avLst/>
             </a:prstGeom>
             <a:solidFill>
-              <a:srgbClr val="9092FF">
+              <a:srgbClr val="8E7CD7">
                 <a:alpha val="100000"/>
               </a:srgbClr>
             </a:solidFill>
@@ -5356,7 +5356,7 @@
               <a:avLst/>
             </a:prstGeom>
             <a:solidFill>
-              <a:srgbClr val="BC82FF">
+              <a:srgbClr val="1EB2D8">
                 <a:alpha val="100000"/>
               </a:srgbClr>
             </a:solidFill>
@@ -5391,7 +5391,7 @@
               <a:avLst/>
             </a:prstGeom>
             <a:solidFill>
-              <a:srgbClr val="DA74F5">
+              <a:srgbClr val="7E57FF">
                 <a:alpha val="100000"/>
               </a:srgbClr>
             </a:solidFill>
@@ -5426,7 +5426,7 @@
               <a:avLst/>
             </a:prstGeom>
             <a:solidFill>
-              <a:srgbClr val="EE6AE4">
+              <a:srgbClr val="F4B5FF">
                 <a:alpha val="100000"/>
               </a:srgbClr>
             </a:solidFill>
@@ -5461,7 +5461,7 @@
               <a:avLst/>
             </a:prstGeom>
             <a:solidFill>
-              <a:srgbClr val="F966CD">
+              <a:srgbClr val="F4A100">
                 <a:alpha val="100000"/>
               </a:srgbClr>
             </a:solidFill>
@@ -5496,7 +5496,7 @@
               <a:avLst/>
             </a:prstGeom>
             <a:solidFill>
-              <a:srgbClr val="FD68B2">
+              <a:srgbClr val="FF5CB8">
                 <a:alpha val="100000"/>
               </a:srgbClr>
             </a:solidFill>
@@ -5531,7 +5531,7 @@
               <a:avLst/>
             </a:prstGeom>
             <a:solidFill>
-              <a:srgbClr val="FB6F93">
+              <a:srgbClr val="F04E98">
                 <a:alpha val="100000"/>
               </a:srgbClr>
             </a:solidFill>
@@ -5566,7 +5566,7 @@
               <a:avLst/>
             </a:prstGeom>
             <a:solidFill>
-              <a:srgbClr val="F57870">
+              <a:srgbClr val="F06A6A">
                 <a:alpha val="100000"/>
               </a:srgbClr>
             </a:solidFill>

</xml_diff>